<commit_message>
Reporte portadas en pptx
</commit_message>
<xml_diff>
--- a/Reporte 021026.pptx
+++ b/Reporte 021026.pptx
@@ -5,7 +5,7 @@
     <p:sldMasterId id="2147483672" r:id="rId1"/>
   </p:sldMasterIdLst>
   <p:notesMasterIdLst>
-    <p:notesMasterId r:id="rId20"/>
+    <p:notesMasterId r:id="rId19"/>
   </p:notesMasterIdLst>
   <p:sldIdLst>
     <p:sldId id="350" r:id="rId2"/>
@@ -13,34 +13,33 @@
     <p:sldId id="408" r:id="rId4"/>
     <p:sldId id="405" r:id="rId5"/>
     <p:sldId id="406" r:id="rId6"/>
-    <p:sldId id="418" r:id="rId7"/>
-    <p:sldId id="394" r:id="rId8"/>
-    <p:sldId id="395" r:id="rId9"/>
-    <p:sldId id="396" r:id="rId10"/>
-    <p:sldId id="403" r:id="rId11"/>
-    <p:sldId id="388" r:id="rId12"/>
-    <p:sldId id="351" r:id="rId13"/>
-    <p:sldId id="361" r:id="rId14"/>
-    <p:sldId id="412" r:id="rId15"/>
-    <p:sldId id="371" r:id="rId16"/>
-    <p:sldId id="419" r:id="rId17"/>
-    <p:sldId id="413" r:id="rId18"/>
-    <p:sldId id="280" r:id="rId19"/>
+    <p:sldId id="394" r:id="rId7"/>
+    <p:sldId id="395" r:id="rId8"/>
+    <p:sldId id="396" r:id="rId9"/>
+    <p:sldId id="403" r:id="rId10"/>
+    <p:sldId id="388" r:id="rId11"/>
+    <p:sldId id="351" r:id="rId12"/>
+    <p:sldId id="361" r:id="rId13"/>
+    <p:sldId id="412" r:id="rId14"/>
+    <p:sldId id="371" r:id="rId15"/>
+    <p:sldId id="419" r:id="rId16"/>
+    <p:sldId id="413" r:id="rId17"/>
+    <p:sldId id="280" r:id="rId18"/>
   </p:sldIdLst>
   <p:sldSz cx="9144000" cy="5143500" type="screen16x9"/>
   <p:notesSz cx="6858000" cy="9144000"/>
   <p:embeddedFontLst>
     <p:embeddedFont>
       <p:font typeface="Montserrat" panose="00000500000000000000" pitchFamily="2" charset="0"/>
-      <p:regular r:id="rId21"/>
-      <p:bold r:id="rId22"/>
-      <p:italic r:id="rId23"/>
-      <p:boldItalic r:id="rId24"/>
+      <p:regular r:id="rId20"/>
+      <p:bold r:id="rId21"/>
+      <p:italic r:id="rId22"/>
+      <p:boldItalic r:id="rId23"/>
     </p:embeddedFont>
     <p:embeddedFont>
       <p:font typeface="Montserrat Black" panose="00000A00000000000000" pitchFamily="2" charset="0"/>
-      <p:bold r:id="rId25"/>
-      <p:boldItalic r:id="rId26"/>
+      <p:bold r:id="rId24"/>
+      <p:boldItalic r:id="rId25"/>
     </p:embeddedFont>
   </p:embeddedFontLst>
   <p:defaultTextStyle>
@@ -1087,90 +1086,6 @@
         <p:cNvPr id="1" name="">
           <a:extLst>
             <a:ext uri="{FF2B5EF4-FFF2-40B4-BE49-F238E27FC236}">
-              <a16:creationId xmlns:a16="http://schemas.microsoft.com/office/drawing/2014/main" id="{59B6EFC6-BD0D-E957-DA3B-E452429CF477}"/>
-            </a:ext>
-          </a:extLst>
-        </p:cNvPr>
-        <p:cNvGrpSpPr/>
-        <p:nvPr/>
-      </p:nvGrpSpPr>
-      <p:grpSpPr>
-        <a:xfrm>
-          <a:off x="0" y="0"/>
-          <a:ext cx="0" cy="0"/>
-          <a:chOff x="0" y="0"/>
-          <a:chExt cx="0" cy="0"/>
-        </a:xfrm>
-      </p:grpSpPr>
-      <p:sp>
-        <p:nvSpPr>
-          <p:cNvPr id="2" name="Marcador de imagen de diapositiva 1">
-            <a:extLst>
-              <a:ext uri="{FF2B5EF4-FFF2-40B4-BE49-F238E27FC236}">
-                <a16:creationId xmlns:a16="http://schemas.microsoft.com/office/drawing/2014/main" id="{9D4C07A2-3A66-A51B-91E4-B930F3ED1D02}"/>
-              </a:ext>
-            </a:extLst>
-          </p:cNvPr>
-          <p:cNvSpPr>
-            <a:spLocks noGrp="1" noRot="1" noChangeAspect="1"/>
-          </p:cNvSpPr>
-          <p:nvPr>
-            <p:ph type="sldImg"/>
-          </p:nvPr>
-        </p:nvSpPr>
-        <p:spPr>
-          <a:xfrm>
-            <a:off x="381000" y="685800"/>
-            <a:ext cx="6096000" cy="3429000"/>
-          </a:xfrm>
-        </p:spPr>
-      </p:sp>
-      <p:sp>
-        <p:nvSpPr>
-          <p:cNvPr id="3" name="Marcador de notas 2">
-            <a:extLst>
-              <a:ext uri="{FF2B5EF4-FFF2-40B4-BE49-F238E27FC236}">
-                <a16:creationId xmlns:a16="http://schemas.microsoft.com/office/drawing/2014/main" id="{FAC49ADD-CE59-ADCA-64AA-AFDE04977F70}"/>
-              </a:ext>
-            </a:extLst>
-          </p:cNvPr>
-          <p:cNvSpPr>
-            <a:spLocks noGrp="1"/>
-          </p:cNvSpPr>
-          <p:nvPr>
-            <p:ph type="body" idx="1"/>
-          </p:nvPr>
-        </p:nvSpPr>
-        <p:spPr/>
-        <p:txBody>
-          <a:bodyPr/>
-          <a:lstStyle/>
-          <a:p>
-            <a:endParaRPr lang="es-MX" dirty="0"/>
-          </a:p>
-        </p:txBody>
-      </p:sp>
-    </p:spTree>
-    <p:extLst>
-      <p:ext uri="{BB962C8B-B14F-4D97-AF65-F5344CB8AC3E}">
-        <p14:creationId xmlns:p14="http://schemas.microsoft.com/office/powerpoint/2010/main" val="349275382"/>
-      </p:ext>
-    </p:extLst>
-  </p:cSld>
-  <p:clrMapOvr>
-    <a:masterClrMapping/>
-  </p:clrMapOvr>
-</p:notes>
-</file>
-
-<file path=ppt/notesSlides/notesSlide6.xml><?xml version="1.0" encoding="utf-8"?>
-<p:notes xmlns:a="http://schemas.openxmlformats.org/drawingml/2006/main" xmlns:r="http://schemas.openxmlformats.org/officeDocument/2006/relationships" xmlns:p="http://schemas.openxmlformats.org/presentationml/2006/main">
-  <p:cSld>
-    <p:spTree>
-      <p:nvGrpSpPr>
-        <p:cNvPr id="1" name="">
-          <a:extLst>
-            <a:ext uri="{FF2B5EF4-FFF2-40B4-BE49-F238E27FC236}">
               <a16:creationId xmlns:a16="http://schemas.microsoft.com/office/drawing/2014/main" id="{357567EE-3B4E-8C48-2AAD-0C70B0A7FC91}"/>
             </a:ext>
           </a:extLst>
@@ -1247,7 +1162,7 @@
 </p:notes>
 </file>
 
-<file path=ppt/notesSlides/notesSlide7.xml><?xml version="1.0" encoding="utf-8"?>
+<file path=ppt/notesSlides/notesSlide6.xml><?xml version="1.0" encoding="utf-8"?>
 <p:notes xmlns:a="http://schemas.openxmlformats.org/drawingml/2006/main" xmlns:r="http://schemas.openxmlformats.org/officeDocument/2006/relationships" xmlns:p="http://schemas.openxmlformats.org/presentationml/2006/main" showMasterSp="0" showMasterPhAnim="0">
   <p:cSld>
     <p:spTree>
@@ -6505,7 +6420,7 @@
                 <a:latin typeface="Montserrat Black"/>
                 <a:sym typeface="Arial"/>
               </a:rPr>
-              <a:t>Elaborado: 01 de octubre</a:t>
+              <a:t>Elaborado: 02 de octubre</a:t>
             </a:r>
             <a:endParaRPr lang="es-MX" sz="1600" dirty="0">
               <a:solidFill>
@@ -6566,124 +6481,6 @@
 </file>
 
 <file path=ppt/slides/slide10.xml><?xml version="1.0" encoding="utf-8"?>
-<p:sld xmlns:a="http://schemas.openxmlformats.org/drawingml/2006/main" xmlns:r="http://schemas.openxmlformats.org/officeDocument/2006/relationships" xmlns:p="http://schemas.openxmlformats.org/presentationml/2006/main">
-  <p:cSld>
-    <p:bg>
-      <p:bgPr>
-        <a:solidFill>
-          <a:srgbClr val="FAFAFA"/>
-        </a:solidFill>
-        <a:effectLst/>
-      </p:bgPr>
-    </p:bg>
-    <p:spTree>
-      <p:nvGrpSpPr>
-        <p:cNvPr id="1" name="">
-          <a:extLst>
-            <a:ext uri="{FF2B5EF4-FFF2-40B4-BE49-F238E27FC236}">
-              <a16:creationId xmlns:a16="http://schemas.microsoft.com/office/drawing/2014/main" id="{93B6DC8C-E619-F67B-9048-4615CF198885}"/>
-            </a:ext>
-          </a:extLst>
-        </p:cNvPr>
-        <p:cNvGrpSpPr/>
-        <p:nvPr/>
-      </p:nvGrpSpPr>
-      <p:grpSpPr>
-        <a:xfrm>
-          <a:off x="0" y="0"/>
-          <a:ext cx="0" cy="0"/>
-          <a:chOff x="0" y="0"/>
-          <a:chExt cx="0" cy="0"/>
-        </a:xfrm>
-      </p:grpSpPr>
-      <p:sp>
-        <p:nvSpPr>
-          <p:cNvPr id="7" name="CuadroTexto 6">
-            <a:extLst>
-              <a:ext uri="{FF2B5EF4-FFF2-40B4-BE49-F238E27FC236}">
-                <a16:creationId xmlns:a16="http://schemas.microsoft.com/office/drawing/2014/main" id="{C46A5360-EC76-283F-42C4-C3D1585636DD}"/>
-              </a:ext>
-            </a:extLst>
-          </p:cNvPr>
-          <p:cNvSpPr txBox="1"/>
-          <p:nvPr/>
-        </p:nvSpPr>
-        <p:spPr>
-          <a:xfrm>
-            <a:off x="908175" y="152426"/>
-            <a:ext cx="7254625" cy="369332"/>
-          </a:xfrm>
-          <a:prstGeom prst="rect">
-            <a:avLst/>
-          </a:prstGeom>
-          <a:noFill/>
-        </p:spPr>
-        <p:txBody>
-          <a:bodyPr wrap="square">
-            <a:spAutoFit/>
-          </a:bodyPr>
-          <a:lstStyle/>
-          <a:p>
-            <a:pPr algn="ctr">
-              <a:buNone/>
-            </a:pPr>
-            <a:r>
-              <a:rPr lang="es-MX" sz="1800" b="1" i="0" dirty="0">
-                <a:solidFill>
-                  <a:srgbClr val="000000"/>
-                </a:solidFill>
-                <a:effectLst/>
-                <a:latin typeface="Montserrat" pitchFamily="2" charset="0"/>
-              </a:rPr>
-              <a:t>Detalle de Notas en primeras planas</a:t>
-            </a:r>
-          </a:p>
-        </p:txBody>
-      </p:sp>
-      <p:pic>
-        <p:nvPicPr>
-          <p:cNvPr id="3" name="Imagen 2">
-            <a:extLst>
-              <a:ext uri="{FF2B5EF4-FFF2-40B4-BE49-F238E27FC236}">
-                <a16:creationId xmlns:a16="http://schemas.microsoft.com/office/drawing/2014/main" id="{54271E3D-FAE2-E860-AA74-49F079DCFDD0}"/>
-              </a:ext>
-            </a:extLst>
-          </p:cNvPr>
-          <p:cNvPicPr>
-            <a:picLocks noChangeAspect="1"/>
-          </p:cNvPicPr>
-          <p:nvPr/>
-        </p:nvPicPr>
-        <p:blipFill>
-          <a:blip r:embed="rId3"/>
-          <a:stretch>
-            <a:fillRect/>
-          </a:stretch>
-        </p:blipFill>
-        <p:spPr>
-          <a:xfrm>
-            <a:off x="2711449" y="909638"/>
-            <a:ext cx="3648075" cy="3467100"/>
-          </a:xfrm>
-          <a:prstGeom prst="rect">
-            <a:avLst/>
-          </a:prstGeom>
-        </p:spPr>
-      </p:pic>
-    </p:spTree>
-    <p:extLst>
-      <p:ext uri="{BB962C8B-B14F-4D97-AF65-F5344CB8AC3E}">
-        <p14:creationId xmlns:p14="http://schemas.microsoft.com/office/powerpoint/2010/main" val="2442859157"/>
-      </p:ext>
-    </p:extLst>
-  </p:cSld>
-  <p:clrMapOvr>
-    <a:masterClrMapping/>
-  </p:clrMapOvr>
-</p:sld>
-</file>
-
-<file path=ppt/slides/slide11.xml><?xml version="1.0" encoding="utf-8"?>
 <p:sld xmlns:a="http://schemas.openxmlformats.org/drawingml/2006/main" xmlns:r="http://schemas.openxmlformats.org/officeDocument/2006/relationships" xmlns:p="http://schemas.openxmlformats.org/presentationml/2006/main">
   <p:cSld>
     <p:bg>
@@ -6795,7 +6592,7 @@
 </p:sld>
 </file>
 
-<file path=ppt/slides/slide12.xml><?xml version="1.0" encoding="utf-8"?>
+<file path=ppt/slides/slide11.xml><?xml version="1.0" encoding="utf-8"?>
 <p:sld xmlns:a="http://schemas.openxmlformats.org/drawingml/2006/main" xmlns:r="http://schemas.openxmlformats.org/officeDocument/2006/relationships" xmlns:p="http://schemas.openxmlformats.org/presentationml/2006/main">
   <p:cSld>
     <p:bg>
@@ -6901,7 +6698,7 @@
 </p:sld>
 </file>
 
-<file path=ppt/slides/slide13.xml><?xml version="1.0" encoding="utf-8"?>
+<file path=ppt/slides/slide12.xml><?xml version="1.0" encoding="utf-8"?>
 <p:sld xmlns:a="http://schemas.openxmlformats.org/drawingml/2006/main" xmlns:r="http://schemas.openxmlformats.org/officeDocument/2006/relationships" xmlns:p="http://schemas.openxmlformats.org/presentationml/2006/main">
   <p:cSld>
     <p:bg>
@@ -7007,7 +6804,7 @@
 </p:sld>
 </file>
 
-<file path=ppt/slides/slide14.xml><?xml version="1.0" encoding="utf-8"?>
+<file path=ppt/slides/slide13.xml><?xml version="1.0" encoding="utf-8"?>
 <p:sld xmlns:a="http://schemas.openxmlformats.org/drawingml/2006/main" xmlns:r="http://schemas.openxmlformats.org/officeDocument/2006/relationships" xmlns:p="http://schemas.openxmlformats.org/presentationml/2006/main">
   <p:cSld>
     <p:bg>
@@ -7113,7 +6910,7 @@
 </p:sld>
 </file>
 
-<file path=ppt/slides/slide15.xml><?xml version="1.0" encoding="utf-8"?>
+<file path=ppt/slides/slide14.xml><?xml version="1.0" encoding="utf-8"?>
 <p:sld xmlns:a="http://schemas.openxmlformats.org/drawingml/2006/main" xmlns:r="http://schemas.openxmlformats.org/officeDocument/2006/relationships" xmlns:p="http://schemas.openxmlformats.org/presentationml/2006/main">
   <p:cSld>
     <p:bg>
@@ -7219,7 +7016,7 @@
 </p:sld>
 </file>
 
-<file path=ppt/slides/slide16.xml><?xml version="1.0" encoding="utf-8"?>
+<file path=ppt/slides/slide15.xml><?xml version="1.0" encoding="utf-8"?>
 <p:sld xmlns:a="http://schemas.openxmlformats.org/drawingml/2006/main" xmlns:r="http://schemas.openxmlformats.org/officeDocument/2006/relationships" xmlns:p="http://schemas.openxmlformats.org/presentationml/2006/main">
   <p:cSld>
     <p:bg>
@@ -7331,7 +7128,7 @@
 </p:sld>
 </file>
 
-<file path=ppt/slides/slide17.xml><?xml version="1.0" encoding="utf-8"?>
+<file path=ppt/slides/slide16.xml><?xml version="1.0" encoding="utf-8"?>
 <p:sld xmlns:a="http://schemas.openxmlformats.org/drawingml/2006/main" xmlns:r="http://schemas.openxmlformats.org/officeDocument/2006/relationships" xmlns:p="http://schemas.openxmlformats.org/presentationml/2006/main">
   <p:cSld>
     <p:bg>
@@ -7443,7 +7240,7 @@
 </p:sld>
 </file>
 
-<file path=ppt/slides/slide18.xml><?xml version="1.0" encoding="utf-8"?>
+<file path=ppt/slides/slide17.xml><?xml version="1.0" encoding="utf-8"?>
 <p:sld xmlns:a="http://schemas.openxmlformats.org/drawingml/2006/main" xmlns:r="http://schemas.openxmlformats.org/officeDocument/2006/relationships" xmlns:p="http://schemas.openxmlformats.org/presentationml/2006/main">
   <p:cSld>
     <p:spTree>
@@ -7576,10 +7373,10 @@
       </p:sp>
       <p:pic>
         <p:nvPicPr>
-          <p:cNvPr id="4" name="Imagen 3">
+          <p:cNvPr id="3" name="Imagen 2">
             <a:extLst>
               <a:ext uri="{FF2B5EF4-FFF2-40B4-BE49-F238E27FC236}">
-                <a16:creationId xmlns:a16="http://schemas.microsoft.com/office/drawing/2014/main" id="{C7EF3EBA-6B2B-E541-5BE3-C410FAACB774}"/>
+                <a16:creationId xmlns:a16="http://schemas.microsoft.com/office/drawing/2014/main" id="{22F120EF-523E-D3B8-EEBD-A5E1E6340054}"/>
               </a:ext>
             </a:extLst>
           </p:cNvPr>
@@ -7596,8 +7393,8 @@
         </p:blipFill>
         <p:spPr>
           <a:xfrm>
-            <a:off x="0" y="633300"/>
-            <a:ext cx="9144000" cy="4136100"/>
+            <a:off x="0" y="707800"/>
+            <a:ext cx="9144000" cy="3727900"/>
           </a:xfrm>
           <a:prstGeom prst="rect">
             <a:avLst/>
@@ -7690,10 +7487,10 @@
       </p:sp>
       <p:pic>
         <p:nvPicPr>
-          <p:cNvPr id="6" name="Imagen 5">
+          <p:cNvPr id="3" name="Imagen 2">
             <a:extLst>
               <a:ext uri="{FF2B5EF4-FFF2-40B4-BE49-F238E27FC236}">
-                <a16:creationId xmlns:a16="http://schemas.microsoft.com/office/drawing/2014/main" id="{3D70CE1B-3C74-C797-A962-EC7AD72EF067}"/>
+                <a16:creationId xmlns:a16="http://schemas.microsoft.com/office/drawing/2014/main" id="{12E7D02A-4EA3-CF9F-461D-4252A99BD3D3}"/>
               </a:ext>
             </a:extLst>
           </p:cNvPr>
@@ -7710,8 +7507,8 @@
         </p:blipFill>
         <p:spPr>
           <a:xfrm>
-            <a:off x="0" y="1086815"/>
-            <a:ext cx="9144000" cy="3112745"/>
+            <a:off x="0" y="1411405"/>
+            <a:ext cx="9144000" cy="2463565"/>
           </a:xfrm>
           <a:prstGeom prst="rect">
             <a:avLst/>
@@ -7804,10 +7601,10 @@
       </p:sp>
       <p:pic>
         <p:nvPicPr>
-          <p:cNvPr id="2" name="Imagen 1">
+          <p:cNvPr id="3" name="Imagen 2">
             <a:extLst>
               <a:ext uri="{FF2B5EF4-FFF2-40B4-BE49-F238E27FC236}">
-                <a16:creationId xmlns:a16="http://schemas.microsoft.com/office/drawing/2014/main" id="{E7DD2D1E-4B16-8B67-9356-45BB5E9DD53F}"/>
+                <a16:creationId xmlns:a16="http://schemas.microsoft.com/office/drawing/2014/main" id="{3A054867-C272-4F68-ED27-510025E2078B}"/>
               </a:ext>
             </a:extLst>
           </p:cNvPr>
@@ -7824,8 +7621,8 @@
         </p:blipFill>
         <p:spPr>
           <a:xfrm>
-            <a:off x="1486662" y="691088"/>
-            <a:ext cx="6097651" cy="3904200"/>
+            <a:off x="1149897" y="691088"/>
+            <a:ext cx="6844205" cy="3904200"/>
           </a:xfrm>
           <a:prstGeom prst="rect">
             <a:avLst/>
@@ -7914,10 +7711,10 @@
       </p:sp>
       <p:pic>
         <p:nvPicPr>
-          <p:cNvPr id="4" name="Imagen 3">
+          <p:cNvPr id="3" name="Imagen 2">
             <a:extLst>
               <a:ext uri="{FF2B5EF4-FFF2-40B4-BE49-F238E27FC236}">
-                <a16:creationId xmlns:a16="http://schemas.microsoft.com/office/drawing/2014/main" id="{BDE5457F-95B5-BA8E-6A0C-F05F7B160B7E}"/>
+                <a16:creationId xmlns:a16="http://schemas.microsoft.com/office/drawing/2014/main" id="{19536C22-A229-3365-CA1C-8FF72E97C365}"/>
               </a:ext>
             </a:extLst>
           </p:cNvPr>
@@ -7934,8 +7731,8 @@
         </p:blipFill>
         <p:spPr>
           <a:xfrm>
-            <a:off x="625474" y="1700213"/>
-            <a:ext cx="7820025" cy="1885950"/>
+            <a:off x="600075" y="766763"/>
+            <a:ext cx="7943850" cy="3752850"/>
           </a:xfrm>
           <a:prstGeom prst="rect">
             <a:avLst/>
@@ -7956,116 +7753,6 @@
 </file>
 
 <file path=ppt/slides/slide6.xml><?xml version="1.0" encoding="utf-8"?>
-<p:sld xmlns:a="http://schemas.openxmlformats.org/drawingml/2006/main" xmlns:r="http://schemas.openxmlformats.org/officeDocument/2006/relationships" xmlns:p="http://schemas.openxmlformats.org/presentationml/2006/main">
-  <p:cSld>
-    <p:spTree>
-      <p:nvGrpSpPr>
-        <p:cNvPr id="1" name="">
-          <a:extLst>
-            <a:ext uri="{FF2B5EF4-FFF2-40B4-BE49-F238E27FC236}">
-              <a16:creationId xmlns:a16="http://schemas.microsoft.com/office/drawing/2014/main" id="{0ECEF1BD-C1B8-3631-07EC-961DDE71F8BB}"/>
-            </a:ext>
-          </a:extLst>
-        </p:cNvPr>
-        <p:cNvGrpSpPr/>
-        <p:nvPr/>
-      </p:nvGrpSpPr>
-      <p:grpSpPr>
-        <a:xfrm>
-          <a:off x="0" y="0"/>
-          <a:ext cx="0" cy="0"/>
-          <a:chOff x="0" y="0"/>
-          <a:chExt cx="0" cy="0"/>
-        </a:xfrm>
-      </p:grpSpPr>
-      <p:sp>
-        <p:nvSpPr>
-          <p:cNvPr id="7" name="CuadroTexto 6">
-            <a:extLst>
-              <a:ext uri="{FF2B5EF4-FFF2-40B4-BE49-F238E27FC236}">
-                <a16:creationId xmlns:a16="http://schemas.microsoft.com/office/drawing/2014/main" id="{9F2DBA7C-A758-8E46-5CEF-A5CE898CE74E}"/>
-              </a:ext>
-            </a:extLst>
-          </p:cNvPr>
-          <p:cNvSpPr txBox="1"/>
-          <p:nvPr/>
-        </p:nvSpPr>
-        <p:spPr>
-          <a:xfrm>
-            <a:off x="908175" y="152426"/>
-            <a:ext cx="7254625" cy="369332"/>
-          </a:xfrm>
-          <a:prstGeom prst="rect">
-            <a:avLst/>
-          </a:prstGeom>
-          <a:noFill/>
-        </p:spPr>
-        <p:txBody>
-          <a:bodyPr wrap="square">
-            <a:spAutoFit/>
-          </a:bodyPr>
-          <a:lstStyle/>
-          <a:p>
-            <a:pPr algn="ctr">
-              <a:buNone/>
-            </a:pPr>
-            <a:r>
-              <a:rPr lang="es-MX" sz="1800" b="1" i="0" dirty="0">
-                <a:solidFill>
-                  <a:srgbClr val="000000"/>
-                </a:solidFill>
-                <a:effectLst/>
-                <a:latin typeface="Montserrat" pitchFamily="2" charset="0"/>
-              </a:rPr>
-              <a:t>Detalle de Notas en primeras planas</a:t>
-            </a:r>
-          </a:p>
-        </p:txBody>
-      </p:sp>
-      <p:pic>
-        <p:nvPicPr>
-          <p:cNvPr id="3" name="Imagen 2">
-            <a:extLst>
-              <a:ext uri="{FF2B5EF4-FFF2-40B4-BE49-F238E27FC236}">
-                <a16:creationId xmlns:a16="http://schemas.microsoft.com/office/drawing/2014/main" id="{7DA456A9-BD20-37D1-7D01-55AD403E8A24}"/>
-              </a:ext>
-            </a:extLst>
-          </p:cNvPr>
-          <p:cNvPicPr>
-            <a:picLocks noChangeAspect="1"/>
-          </p:cNvPicPr>
-          <p:nvPr/>
-        </p:nvPicPr>
-        <p:blipFill>
-          <a:blip r:embed="rId3"/>
-          <a:stretch>
-            <a:fillRect/>
-          </a:stretch>
-        </p:blipFill>
-        <p:spPr>
-          <a:xfrm>
-            <a:off x="647700" y="838200"/>
-            <a:ext cx="7848600" cy="3609975"/>
-          </a:xfrm>
-          <a:prstGeom prst="rect">
-            <a:avLst/>
-          </a:prstGeom>
-        </p:spPr>
-      </p:pic>
-    </p:spTree>
-    <p:extLst>
-      <p:ext uri="{BB962C8B-B14F-4D97-AF65-F5344CB8AC3E}">
-        <p14:creationId xmlns:p14="http://schemas.microsoft.com/office/powerpoint/2010/main" val="3607150089"/>
-      </p:ext>
-    </p:extLst>
-  </p:cSld>
-  <p:clrMapOvr>
-    <a:masterClrMapping/>
-  </p:clrMapOvr>
-</p:sld>
-</file>
-
-<file path=ppt/slides/slide7.xml><?xml version="1.0" encoding="utf-8"?>
 <p:sld xmlns:a="http://schemas.openxmlformats.org/drawingml/2006/main" xmlns:r="http://schemas.openxmlformats.org/officeDocument/2006/relationships" xmlns:p="http://schemas.openxmlformats.org/presentationml/2006/main">
   <p:cSld>
     <p:bg>
@@ -8138,10 +7825,10 @@
       </p:sp>
       <p:pic>
         <p:nvPicPr>
-          <p:cNvPr id="4" name="Imagen 3">
+          <p:cNvPr id="3" name="Imagen 2">
             <a:extLst>
               <a:ext uri="{FF2B5EF4-FFF2-40B4-BE49-F238E27FC236}">
-                <a16:creationId xmlns:a16="http://schemas.microsoft.com/office/drawing/2014/main" id="{981123CB-29C4-DE6F-35B5-6A76113AEEC9}"/>
+                <a16:creationId xmlns:a16="http://schemas.microsoft.com/office/drawing/2014/main" id="{D21FA289-95B7-E8F0-E9D2-45B0BC95D7DC}"/>
               </a:ext>
             </a:extLst>
           </p:cNvPr>
@@ -8158,8 +7845,8 @@
         </p:blipFill>
         <p:spPr>
           <a:xfrm>
-            <a:off x="0" y="563425"/>
-            <a:ext cx="9144000" cy="4159526"/>
+            <a:off x="0" y="579850"/>
+            <a:ext cx="9144000" cy="4126675"/>
           </a:xfrm>
           <a:prstGeom prst="rect">
             <a:avLst/>
@@ -8179,7 +7866,7 @@
 </p:sld>
 </file>
 
-<file path=ppt/slides/slide8.xml><?xml version="1.0" encoding="utf-8"?>
+<file path=ppt/slides/slide7.xml><?xml version="1.0" encoding="utf-8"?>
 <p:sld xmlns:a="http://schemas.openxmlformats.org/drawingml/2006/main" xmlns:r="http://schemas.openxmlformats.org/officeDocument/2006/relationships" xmlns:p="http://schemas.openxmlformats.org/presentationml/2006/main">
   <p:cSld>
     <p:bg>
@@ -8252,10 +7939,10 @@
       </p:sp>
       <p:pic>
         <p:nvPicPr>
-          <p:cNvPr id="2" name="Imagen 1">
+          <p:cNvPr id="3" name="Imagen 2">
             <a:extLst>
               <a:ext uri="{FF2B5EF4-FFF2-40B4-BE49-F238E27FC236}">
-                <a16:creationId xmlns:a16="http://schemas.microsoft.com/office/drawing/2014/main" id="{4955BF2D-2B46-3F44-106D-47B026B1B550}"/>
+                <a16:creationId xmlns:a16="http://schemas.microsoft.com/office/drawing/2014/main" id="{5D0181A8-0E46-CA3B-43F7-77A351A839AD}"/>
               </a:ext>
             </a:extLst>
           </p:cNvPr>
@@ -8272,7 +7959,7 @@
         </p:blipFill>
         <p:spPr>
           <a:xfrm>
-            <a:off x="1486662" y="830700"/>
+            <a:off x="1486662" y="1176300"/>
             <a:ext cx="6097651" cy="3904200"/>
           </a:xfrm>
           <a:prstGeom prst="rect">
@@ -8293,7 +7980,7 @@
 </p:sld>
 </file>
 
-<file path=ppt/slides/slide9.xml><?xml version="1.0" encoding="utf-8"?>
+<file path=ppt/slides/slide8.xml><?xml version="1.0" encoding="utf-8"?>
 <p:sld xmlns:a="http://schemas.openxmlformats.org/drawingml/2006/main" xmlns:r="http://schemas.openxmlformats.org/officeDocument/2006/relationships" xmlns:p="http://schemas.openxmlformats.org/presentationml/2006/main">
   <p:cSld>
     <p:bg>
@@ -8366,10 +8053,10 @@
       </p:sp>
       <p:pic>
         <p:nvPicPr>
-          <p:cNvPr id="2" name="Imagen 1">
+          <p:cNvPr id="3" name="Imagen 2">
             <a:extLst>
               <a:ext uri="{FF2B5EF4-FFF2-40B4-BE49-F238E27FC236}">
-                <a16:creationId xmlns:a16="http://schemas.microsoft.com/office/drawing/2014/main" id="{8D34BF10-D6FB-939C-483D-3C8F52F7AC34}"/>
+                <a16:creationId xmlns:a16="http://schemas.microsoft.com/office/drawing/2014/main" id="{44D25AA5-2B99-5D61-9EDE-E7F5BAF948C5}"/>
               </a:ext>
             </a:extLst>
           </p:cNvPr>
@@ -8398,6 +8085,154 @@
     <p:extLst>
       <p:ext uri="{BB962C8B-B14F-4D97-AF65-F5344CB8AC3E}">
         <p14:creationId xmlns:p14="http://schemas.microsoft.com/office/powerpoint/2010/main" val="3736623944"/>
+      </p:ext>
+    </p:extLst>
+  </p:cSld>
+  <p:clrMapOvr>
+    <a:masterClrMapping/>
+  </p:clrMapOvr>
+</p:sld>
+</file>
+
+<file path=ppt/slides/slide9.xml><?xml version="1.0" encoding="utf-8"?>
+<p:sld xmlns:a="http://schemas.openxmlformats.org/drawingml/2006/main" xmlns:r="http://schemas.openxmlformats.org/officeDocument/2006/relationships" xmlns:p="http://schemas.openxmlformats.org/presentationml/2006/main">
+  <p:cSld>
+    <p:bg>
+      <p:bgPr>
+        <a:solidFill>
+          <a:srgbClr val="FAFAFA"/>
+        </a:solidFill>
+        <a:effectLst/>
+      </p:bgPr>
+    </p:bg>
+    <p:spTree>
+      <p:nvGrpSpPr>
+        <p:cNvPr id="1" name="">
+          <a:extLst>
+            <a:ext uri="{FF2B5EF4-FFF2-40B4-BE49-F238E27FC236}">
+              <a16:creationId xmlns:a16="http://schemas.microsoft.com/office/drawing/2014/main" id="{93B6DC8C-E619-F67B-9048-4615CF198885}"/>
+            </a:ext>
+          </a:extLst>
+        </p:cNvPr>
+        <p:cNvGrpSpPr/>
+        <p:nvPr/>
+      </p:nvGrpSpPr>
+      <p:grpSpPr>
+        <a:xfrm>
+          <a:off x="0" y="0"/>
+          <a:ext cx="0" cy="0"/>
+          <a:chOff x="0" y="0"/>
+          <a:chExt cx="0" cy="0"/>
+        </a:xfrm>
+      </p:grpSpPr>
+      <p:sp>
+        <p:nvSpPr>
+          <p:cNvPr id="7" name="CuadroTexto 6">
+            <a:extLst>
+              <a:ext uri="{FF2B5EF4-FFF2-40B4-BE49-F238E27FC236}">
+                <a16:creationId xmlns:a16="http://schemas.microsoft.com/office/drawing/2014/main" id="{C46A5360-EC76-283F-42C4-C3D1585636DD}"/>
+              </a:ext>
+            </a:extLst>
+          </p:cNvPr>
+          <p:cNvSpPr txBox="1"/>
+          <p:nvPr/>
+        </p:nvSpPr>
+        <p:spPr>
+          <a:xfrm>
+            <a:off x="908175" y="152426"/>
+            <a:ext cx="7254625" cy="369332"/>
+          </a:xfrm>
+          <a:prstGeom prst="rect">
+            <a:avLst/>
+          </a:prstGeom>
+          <a:noFill/>
+        </p:spPr>
+        <p:txBody>
+          <a:bodyPr wrap="square">
+            <a:spAutoFit/>
+          </a:bodyPr>
+          <a:lstStyle/>
+          <a:p>
+            <a:pPr algn="ctr">
+              <a:buNone/>
+            </a:pPr>
+            <a:r>
+              <a:rPr lang="es-MX" sz="1800" b="1" i="0" dirty="0">
+                <a:solidFill>
+                  <a:srgbClr val="000000"/>
+                </a:solidFill>
+                <a:effectLst/>
+                <a:latin typeface="Montserrat" pitchFamily="2" charset="0"/>
+              </a:rPr>
+              <a:t>Detalle de Notas en primeras planas</a:t>
+            </a:r>
+          </a:p>
+        </p:txBody>
+      </p:sp>
+      <p:pic>
+        <p:nvPicPr>
+          <p:cNvPr id="4" name="Imagen 3">
+            <a:extLst>
+              <a:ext uri="{FF2B5EF4-FFF2-40B4-BE49-F238E27FC236}">
+                <a16:creationId xmlns:a16="http://schemas.microsoft.com/office/drawing/2014/main" id="{92635401-8C45-93CA-0B86-499669034F2D}"/>
+              </a:ext>
+            </a:extLst>
+          </p:cNvPr>
+          <p:cNvPicPr>
+            <a:picLocks noChangeAspect="1"/>
+          </p:cNvPicPr>
+          <p:nvPr/>
+        </p:nvPicPr>
+        <p:blipFill>
+          <a:blip r:embed="rId3"/>
+          <a:stretch>
+            <a:fillRect/>
+          </a:stretch>
+        </p:blipFill>
+        <p:spPr>
+          <a:xfrm>
+            <a:off x="2525713" y="646542"/>
+            <a:ext cx="4019550" cy="1571625"/>
+          </a:xfrm>
+          <a:prstGeom prst="rect">
+            <a:avLst/>
+          </a:prstGeom>
+        </p:spPr>
+      </p:pic>
+      <p:pic>
+        <p:nvPicPr>
+          <p:cNvPr id="6" name="Imagen 5">
+            <a:extLst>
+              <a:ext uri="{FF2B5EF4-FFF2-40B4-BE49-F238E27FC236}">
+                <a16:creationId xmlns:a16="http://schemas.microsoft.com/office/drawing/2014/main" id="{D60A0A9A-B8A0-31E4-72A7-E6851AAD1AB5}"/>
+              </a:ext>
+            </a:extLst>
+          </p:cNvPr>
+          <p:cNvPicPr>
+            <a:picLocks noChangeAspect="1"/>
+          </p:cNvPicPr>
+          <p:nvPr/>
+        </p:nvPicPr>
+        <p:blipFill>
+          <a:blip r:embed="rId4"/>
+          <a:stretch>
+            <a:fillRect/>
+          </a:stretch>
+        </p:blipFill>
+        <p:spPr>
+          <a:xfrm>
+            <a:off x="-36512" y="2342951"/>
+            <a:ext cx="9144000" cy="2648123"/>
+          </a:xfrm>
+          <a:prstGeom prst="rect">
+            <a:avLst/>
+          </a:prstGeom>
+        </p:spPr>
+      </p:pic>
+    </p:spTree>
+    <p:extLst>
+      <p:ext uri="{BB962C8B-B14F-4D97-AF65-F5344CB8AC3E}">
+        <p14:creationId xmlns:p14="http://schemas.microsoft.com/office/powerpoint/2010/main" val="2442859157"/>
       </p:ext>
     </p:extLst>
   </p:cSld>

</xml_diff>